<commit_message>
Remove travessoes do texto dos slides
Substitui os 6 travessoes (em dash) por pontuacao corrente, para o texto
soar redigido e nao gerado automaticamente:

- s02: "...documental completa, da coleta a destinacao final..."
- s04: "Situacao atual da area livre do Ecoponto Belezinho"
- s07: "PICOTAGEM (atividade derivada): adequacao dos materiais..."
- s08: "Vao coberto do Ecoponto, area prevista para segregacao..."
- s17: "...nesta etapa. Representacao conceitual, sem carater..."
- s20: "...nesta fase. O cronograma sera estabelecido..."

Verificado: zero em dash / en dash no texto dos 21 slides; layouts sem
alteracao de quebra ou estouro. PPTX, PDF e copia Calibri regerados.
</commit_message>
<xml_diff>
--- a/apresentacoes/bioma_textil/Nunes_Lucato_Bioma_Textil_Ecoponto_Belezinho.pptx
+++ b/apresentacoes/bioma_textil/Nunes_Lucato_Bioma_Textil_Ecoponto_Belezinho.pptx
@@ -28013,7 +28013,7 @@
                 </a:solidFill>
                 <a:latin typeface="Montserrat"/>
               </a:rPr>
-              <a:t>Organização proposta sobre a área existente, sem intervenção estrutural nesta etapa — representação conceitual, sem caráter de projeto executivo ou arquitetônico.</a:t>
+              <a:t>Organização proposta sobre a área existente, sem intervenção estrutural nesta etapa. Representação conceitual, sem caráter de projeto executivo ou arquitetônico.</a:t>
             </a:r>
           </a:p>
         </p:txBody>
@@ -31410,7 +31410,7 @@
                 </a:solidFill>
                 <a:latin typeface="Montserrat"/>
               </a:rPr>
-              <a:t>A Nunes &amp; Lucato atua na cadeia de resíduos têxteis com estrutura própria de transformação, equipe treinada e rastreabilidade documental completa — da coleta à destinação final ambientalmente adequada.</a:t>
+              <a:t>A Nunes &amp; Lucato atua na cadeia de resíduos têxteis com estrutura própria de transformação, equipe treinada e rastreabilidade documental completa, da coleta à destinação final ambientalmente adequada.</a:t>
             </a:r>
           </a:p>
         </p:txBody>
@@ -36653,7 +36653,7 @@
                 </a:solidFill>
                 <a:latin typeface="Montserrat"/>
               </a:rPr>
-              <a:t>Sequência de etapas sem definição de prazos nesta fase — o cronograma será estabelecido em alinhamento com a Prefeitura de São Paulo.</a:t>
+              <a:t>Sequência de etapas sem definição de prazos nesta fase. O cronograma será estabelecido em alinhamento com a Prefeitura de São Paulo.</a:t>
             </a:r>
           </a:p>
         </p:txBody>
@@ -42160,7 +42160,7 @@
                 </a:solidFill>
                 <a:latin typeface="Montserrat"/>
               </a:rPr>
-              <a:t>Área livre do Ecoponto Belezinho — situação atual</a:t>
+              <a:t>Situação atual da área livre do Ecoponto Belezinho</a:t>
             </a:r>
           </a:p>
         </p:txBody>
@@ -49613,7 +49613,7 @@
                 </a:solidFill>
                 <a:latin typeface="Montserrat"/>
               </a:rPr>
-              <a:t>Atividade derivada — PICOTAGEM: adequação dos materiais coletados às especificidades do mercado de desfibramento e coprocessamento.</a:t>
+              <a:t>PICOTAGEM (atividade derivada): adequação dos materiais coletados às especificidades do mercado de desfibramento e coprocessamento.</a:t>
             </a:r>
           </a:p>
         </p:txBody>
@@ -51761,7 +51761,7 @@
                 </a:solidFill>
                 <a:latin typeface="Montserrat"/>
               </a:rPr>
-              <a:t>Vão coberto do Ecoponto — área prevista para segregação e armazenamento</a:t>
+              <a:t>Vão coberto do Ecoponto, área prevista para segregação e armazenamento</a:t>
             </a:r>
           </a:p>
         </p:txBody>

</xml_diff>